<commit_message>
deleted extra csv files
</commit_message>
<xml_diff>
--- a/TOPSIS_Method_Explainer.pptx
+++ b/TOPSIS_Method_Explainer.pptx
@@ -2402,7 +2402,7 @@
                   <a:srgbClr val="3A86FF"/>
                 </a:solidFill>
               </a:rPr>
-              <a:t>Actually More Balanced</a:t>
+              <a:t>More Balanced</a:t>
             </a:r>
             <a:endParaRPr lang="en-US" sz="750" dirty="0"/>
           </a:p>
@@ -3346,7 +3346,7 @@
                   <a:srgbClr val="6B7A99"/>
                 </a:solidFill>
               </a:rPr>
-              <a:t>Under the hood: what the algorithm actually does</a:t>
+              <a:t>Under the hood: what the algorithm does</a:t>
             </a:r>
             <a:endParaRPr lang="en-US" sz="1300" dirty="0"/>
           </a:p>
@@ -4532,7 +4532,7 @@
         </p:nvGraphicFramePr>
         <p:xfrm>
           <a:off x="365760" y="3054096"/>
-          <a:ext cx="4023360" cy="1691640"/>
+          <a:ext cx="4023360" cy="1737360"/>
         </p:xfrm>
         <a:graphic>
           <a:graphicData uri="http://schemas.openxmlformats.org/drawingml/2006/table">

</xml_diff>